<commit_message>
Replace 'tinh bao marketing' with 'thong tin ben ngoai' in session 1
Uses 'he thong thu thap thong tin marketing ben ngoai' (marketing
intelligence) on slides 34 and 36, the lecture notes, outline and plan;
the speaker notes keep one cross-reference to the syllabus term 1.4.2.
Card labels on slide 34 are resized to fit the longer label.

Co-Authored-By: Claude Opus 5.5 <noreply@anthropic.com>
Claude-Session: https://claude.ai/code/session_015TiKUfYtQAUv6eBkcivEqH
</commit_message>
<xml_diff>
--- a/courses/MKT1107/slides/W1_slides_v2.pptx
+++ b/courses/MKT1107/slides/W1_slides_v2.pptx
@@ -3077,8 +3077,8 @@
           <a:p>
             <a:r>
               <a:rPr lang="en-US" dirty="0"/>
-              <a:t>Nói: Hệ thống thông tin marketing (MIS) tích hợp con người, thiết bị và quy trình để thu thập, phân tích và phân phối thông tin chính xác, kịp thời, hỗ trợ nhà quản lý ra quyết định. Bốn bộ phận. Báo cáo nội bộ — nhìn vào trong: đơn hàng, doanh số, tồn kho, kế toán. Tình báo marketing — nhìn ra ngoài: theo dõi liên tục đối thủ, xu hướng, môi trường. MDSS — hệ thống hỗ trợ ra quyết định — là công cụ ra quyết định, ví dụ mô hình dự báo doanh số. Nghiên cứu — dự án: bài toán cụ thể, tại một thời điểm. Báo cáo nội bộ &amp; tình báo: liên tục; mỗi dự án nghiên cứu nằm rải trên dòng đó. Báo cáo nội bộ cho biết doanh số giảm; chỉ nghiên cứu cho biết vì sao.
-(GV: MDSS chỉ nêu 1 câu (slide UEF #16 — MDSS chi tiết — có thể bỏ nếu thiếu giờ). Ví dụ tình báo từ video: các ứng dụng giao đồ ăn theo dõi khuyến mãi của nhau trước khi tung ưu đãi.)
+              <a:t>Nói: Hệ thống thông tin marketing (MIS) tích hợp con người, thiết bị và quy trình để thu thập, phân tích và phân phối thông tin chính xác, kịp thời, hỗ trợ nhà quản lý ra quyết định. Bốn bộ phận. Báo cáo nội bộ — nhìn vào trong: đơn hàng, doanh số, tồn kho, kế toán. Hệ thống thu thập thông tin marketing bên ngoài — nhìn ra ngoài: theo dõi liên tục đối thủ, xu hướng, môi trường, qua báo chí, nhân viên bán hàng, nhà phân phối, báo cáo ngành — thu thập công khai, hợp pháp. MDSS — hệ thống hỗ trợ ra quyết định — là công cụ ra quyết định, ví dụ mô hình dự báo doanh số. Nghiên cứu — dự án: bài toán cụ thể, tại một thời điểm. Báo cáo nội bộ &amp; thông tin bên ngoài: liên tục; mỗi dự án nghiên cứu nằm rải trên dòng đó. Báo cáo nội bộ cho biết doanh số giảm; chỉ nghiên cứu cho biết vì sao.
+(GV: MDSS chỉ nêu 1 câu (slide UEF #16 — MDSS chi tiết — có thể bỏ nếu thiếu giờ). Đối chiếu đề cương: mục 1.4.2 gọi bộ phận này là "Hệ thống tình báo Marketing" (dịch từ marketing intelligence) — nói 1 câu để sinh viên khớp với đề cương: "Đề cương gọi là tình báo marketing; lớp mình gọi là thu thập thông tin bên ngoài cho đúng bản chất: công khai, hợp pháp." Ví dụ thu thập thông tin bên ngoài từ video: các ứng dụng giao đồ ăn theo dõi khuyến mãi của nhau trước khi tung ưu đãi.)
 Hỏi lớp: —
 Chuyển ý: Cuối cùng: ai làm nghiên cứu, và ai dùng nghiên cứu?</a:t>
             </a:r>
@@ -3259,7 +3259,7 @@
           <a:p>
             <a:r>
               <a:rPr lang="en-US" dirty="0"/>
-              <a:t>Nói: Ba câu hỏi kiểm tra nhanh. Một: bước nào quan trọng nhất? Vì sao? Mong đợi: bước 1 — xác định sai vấn đề thì cả nghiên cứu đi sai hướng. Hai: nghiên cứu marketing khác tình báo marketing ở đâu? Mong đợi: nghiên cứu trả lời câu hỏi cụ thể, tại một thời điểm, dạng dự án; tình báo theo dõi liên tục môi trường bên ngoài. Ba: doanh nghiệp nhỏ nên tự làm hay thuê công ty nghiên cứu? Mong đợi: tùy — tự làm thì rẻ, hiểu doanh nghiệp nhưng dễ chủ quan; thuê thì chuyên nghiệp, khách quan nhưng tốn kém. Câu trả lời tốt nêu được cả hai mặt.
+              <a:t>Nói: Ba câu hỏi kiểm tra nhanh. Một: bước nào quan trọng nhất? Vì sao? Mong đợi: bước 1 — xác định sai vấn đề thì cả nghiên cứu đi sai hướng. Hai: nghiên cứu marketing khác thu thập thông tin bên ngoài ở điểm nào? Mong đợi: nghiên cứu trả lời câu hỏi cụ thể, tại một thời điểm, dạng dự án; thu thập thông tin bên ngoài là theo dõi liên tục môi trường bên ngoài. Ba: doanh nghiệp nhỏ nên tự làm hay thuê công ty nghiên cứu? Mong đợi: tùy — tự làm thì rẻ, hiểu doanh nghiệp nhưng dễ chủ quan; thuê thì chuyên nghiệp, khách quan nhưng tốn kém. Câu trả lời tốt nêu được cả hai mặt.
 (GV: Nếu câu 1 hoặc 2 nhiều bạn trả lời sai: dành 1 phút nhắc lại, ghi vào ghi chú sau buổi để ôn ở đầu Buổi 2.)
 Hỏi lớp: Chỉ định phát biểu — mỗi câu 1 bạn, gọi ngẫu nhiên theo danh sách.
 Chuyển ý: Giờ đến lượt các nhóm áp dụng vào đề tài của chính mình.</a:t>
@@ -22153,7 +22153,7 @@
                   <a:schemeClr val="tx1"/>
                 </a:solidFill>
               </a:rPr>
-              <a:t>Tình báo marketing theo dõi liên tục; nghiên cứu marketing trả lời một câu hỏi cụ thể</a:t>
+              <a:t>Thông tin bên ngoài được theo dõi liên tục; nghiên cứu marketing trả lời một câu hỏi cụ thể</a:t>
             </a:r>
             <a:endParaRPr lang="en-US" sz="3000" dirty="0"/>
           </a:p>
@@ -22248,7 +22248,7 @@
         <p:spPr>
           <a:xfrm>
             <a:off x="731520" y="2286000"/>
-            <a:ext cx="2331720" cy="457200"/>
+            <a:ext cx="2331720" cy="731520"/>
           </a:xfrm>
           <a:prstGeom prst="rect">
             <a:avLst/>
@@ -22264,7 +22264,7 @@
               <a:buNone/>
             </a:pPr>
             <a:r>
-              <a:rPr lang="en-US" sz="2400" b="1" dirty="0">
+              <a:rPr lang="en-US" sz="2000" b="1" dirty="0">
                 <a:solidFill>
                   <a:schemeClr val="accent1"/>
                 </a:solidFill>
@@ -22283,8 +22283,8 @@
         </p:nvSpPr>
         <p:spPr>
           <a:xfrm>
-            <a:off x="731520" y="2880360"/>
-            <a:ext cx="2240280" cy="822960"/>
+            <a:off x="731520" y="3063240"/>
+            <a:ext cx="2240280" cy="640080"/>
           </a:xfrm>
           <a:prstGeom prst="rect">
             <a:avLst/>
@@ -22342,7 +22342,7 @@
         <p:spPr>
           <a:xfrm>
             <a:off x="3550615" y="2286000"/>
-            <a:ext cx="2331720" cy="457200"/>
+            <a:ext cx="2331720" cy="731520"/>
           </a:xfrm>
           <a:prstGeom prst="rect">
             <a:avLst/>
@@ -22358,12 +22358,12 @@
               <a:buNone/>
             </a:pPr>
             <a:r>
-              <a:rPr lang="en-US" sz="2400" b="1" dirty="0">
+              <a:rPr lang="en-US" sz="2000" b="1" dirty="0">
                 <a:solidFill>
                   <a:schemeClr val="accent5"/>
                 </a:solidFill>
               </a:rPr>
-              <a:t>Tình báo</a:t>
+              <a:t>Thông tin bên ngoài</a:t>
             </a:r>
             <a:endParaRPr lang="en-US" sz="2400" dirty="0"/>
           </a:p>
@@ -22377,8 +22377,8 @@
         </p:nvSpPr>
         <p:spPr>
           <a:xfrm>
-            <a:off x="3550615" y="2880360"/>
-            <a:ext cx="2240280" cy="822960"/>
+            <a:off x="3550615" y="3063240"/>
+            <a:ext cx="2240280" cy="640080"/>
           </a:xfrm>
           <a:prstGeom prst="rect">
             <a:avLst/>
@@ -22436,7 +22436,7 @@
         <p:spPr>
           <a:xfrm>
             <a:off x="6369710" y="2286000"/>
-            <a:ext cx="2331720" cy="457200"/>
+            <a:ext cx="2331720" cy="731520"/>
           </a:xfrm>
           <a:prstGeom prst="rect">
             <a:avLst/>
@@ -22452,7 +22452,7 @@
               <a:buNone/>
             </a:pPr>
             <a:r>
-              <a:rPr lang="en-US" sz="2400" b="1" dirty="0">
+              <a:rPr lang="en-US" sz="2000" b="1" dirty="0">
                 <a:solidFill>
                   <a:schemeClr val="accent6"/>
                 </a:solidFill>
@@ -22471,8 +22471,8 @@
         </p:nvSpPr>
         <p:spPr>
           <a:xfrm>
-            <a:off x="6369710" y="2880360"/>
-            <a:ext cx="2240280" cy="822960"/>
+            <a:off x="6369710" y="3063240"/>
+            <a:ext cx="2240280" cy="640080"/>
           </a:xfrm>
           <a:prstGeom prst="rect">
             <a:avLst/>
@@ -22530,7 +22530,7 @@
         <p:spPr>
           <a:xfrm>
             <a:off x="9188806" y="2286000"/>
-            <a:ext cx="2331720" cy="457200"/>
+            <a:ext cx="2331720" cy="731520"/>
           </a:xfrm>
           <a:prstGeom prst="rect">
             <a:avLst/>
@@ -22546,7 +22546,7 @@
               <a:buNone/>
             </a:pPr>
             <a:r>
-              <a:rPr lang="en-US" sz="2400" b="1" dirty="0">
+              <a:rPr lang="en-US" sz="2000" b="1" dirty="0">
                 <a:solidFill>
                   <a:schemeClr val="bg1"/>
                 </a:solidFill>
@@ -22565,8 +22565,8 @@
         </p:nvSpPr>
         <p:spPr>
           <a:xfrm>
-            <a:off x="9188806" y="2880360"/>
-            <a:ext cx="2240280" cy="822960"/>
+            <a:off x="9188806" y="3063240"/>
+            <a:ext cx="2240280" cy="640080"/>
           </a:xfrm>
           <a:prstGeom prst="rect">
             <a:avLst/>
@@ -22623,7 +22623,7 @@
                   <a:schemeClr val="accent5"/>
                 </a:solidFill>
               </a:rPr>
-              <a:t>Báo cáo nội bộ &amp; tình báo: liên tục</a:t>
+              <a:t>Báo cáo nội bộ &amp; thông tin bên ngoài: liên tục</a:t>
             </a:r>
             <a:endParaRPr lang="en-US" sz="2400" dirty="0"/>
           </a:p>
@@ -23983,7 +23983,7 @@
                   <a:schemeClr val="tx1"/>
                 </a:solidFill>
               </a:rPr>
-              <a:t>Nghiên cứu marketing khác tình báo marketing ở đâu?</a:t>
+              <a:t>Nghiên cứu marketing khác thu thập thông tin bên ngoài ở điểm nào?</a:t>
             </a:r>
             <a:endParaRPr lang="en-US" sz="2800" dirty="0"/>
           </a:p>

</xml_diff>